<commit_message>
Update SMB bundles monitor deliverables
</commit_message>
<xml_diff>
--- a/deliverables/smb_bundles/smb_bundles_0_opening.pptx
+++ b/deliverables/smb_bundles/smb_bundles_0_opening.pptx
@@ -1736,7 +1736,7 @@
               </a:defRPr>
             </a:pPr>
             <a:r>
-              <a:rPr sz="1200" b="0">
+              <a:rPr sz="1200" b="0" dirty="0">
                 <a:solidFill>
                   <a:srgbClr val="A5A5A5"/>
                 </a:solidFill>
@@ -1744,7 +1744,29 @@
                 <a:ea typeface="Arial"/>
                 <a:cs typeface="Arial"/>
               </a:rPr>
-              <a:t>Use CRM and in-product prompts to grow adoption</a:t>
+              <a:t>Use </a:t>
+            </a:r>
+            <a:r>
+              <a:rPr lang="en-US" sz="1200" dirty="0">
+                <a:solidFill>
+                  <a:srgbClr val="A5A5A5"/>
+                </a:solidFill>
+                <a:latin typeface="Arial"/>
+                <a:ea typeface="Arial"/>
+                <a:cs typeface="Arial"/>
+              </a:rPr>
+              <a:t>Lifecycle</a:t>
+            </a:r>
+            <a:r>
+              <a:rPr sz="1200" b="0" dirty="0">
+                <a:solidFill>
+                  <a:srgbClr val="A5A5A5"/>
+                </a:solidFill>
+                <a:latin typeface="Arial"/>
+                <a:ea typeface="Arial"/>
+                <a:cs typeface="Arial"/>
+              </a:rPr>
+              <a:t> and in-product prompts to grow adoption</a:t>
             </a:r>
           </a:p>
         </p:txBody>

</xml_diff>